<commit_message>
feat(design): upgrade presentation and showcase templates to swiss editorial standards
</commit_message>
<xml_diff>
--- a/src/creative_mcp/editor/assets/artisan-coffee-canva-template.pptx
+++ b/src/creative_mcp/editor/assets/artisan-coffee-canva-template.pptx
@@ -3098,22 +3098,20 @@
       <p:grpSpPr/>
       <p:sp>
         <p:nvSpPr>
-          <p:cNvPr id="2" name="Donut 1"/>
+          <p:cNvPr id="2" name="Rectangle 1"/>
           <p:cNvSpPr/>
           <p:nvPr/>
         </p:nvSpPr>
         <p:spPr>
           <a:xfrm>
-            <a:off x="-666750" y="-666750"/>
-            <a:ext cx="2667000" cy="2667000"/>
-          </a:xfrm>
-          <a:prstGeom prst="donut">
-            <a:avLst>
-              <a:gd name="adj" fmla="val 12000"/>
-            </a:avLst>
+            <a:off x="619125" y="428625"/>
+            <a:ext cx="9048750" cy="9525"/>
+          </a:xfrm>
+          <a:prstGeom prst="rect">
+            <a:avLst/>
           </a:prstGeom>
           <a:solidFill>
-            <a:srgbClr val="D4A373"/>
+            <a:srgbClr val="3A2E26"/>
           </a:solidFill>
           <a:ln>
             <a:noFill/>
@@ -3143,25 +3141,188 @@
       </p:sp>
       <p:sp>
         <p:nvSpPr>
-          <p:cNvPr id="3" name="Donut 2"/>
+          <p:cNvPr id="3" name="TextBox 2"/>
+          <p:cNvSpPr txBox="1"/>
+          <p:nvPr/>
+        </p:nvSpPr>
+        <p:spPr>
+          <a:xfrm>
+            <a:off x="619125" y="523875"/>
+            <a:ext cx="5429250" cy="266700"/>
+          </a:xfrm>
+          <a:prstGeom prst="rect">
+            <a:avLst/>
+          </a:prstGeom>
+          <a:noFill/>
+        </p:spPr>
+        <p:txBody>
+          <a:bodyPr wrap="square" anchor="t">
+            <a:spAutoFit/>
+          </a:bodyPr>
+          <a:lstStyle/>
+          <a:p>
+            <a:pPr algn="l"/>
+            <a:r>
+              <a:rPr sz="900" b="1">
+                <a:solidFill>
+                  <a:srgbClr val="D4A373"/>
+                </a:solidFill>
+                <a:latin typeface="Montserrat"/>
+              </a:rPr>
+              <a:t>SPECIALTY ROASTERY &amp; ESPRESSO BAR</a:t>
+            </a:r>
+          </a:p>
+        </p:txBody>
+      </p:sp>
+      <p:sp>
+        <p:nvSpPr>
+          <p:cNvPr id="4" name="TextBox 3"/>
+          <p:cNvSpPr txBox="1"/>
+          <p:nvPr/>
+        </p:nvSpPr>
+        <p:spPr>
+          <a:xfrm>
+            <a:off x="7762875" y="523875"/>
+            <a:ext cx="1905000" cy="266700"/>
+          </a:xfrm>
+          <a:prstGeom prst="rect">
+            <a:avLst/>
+          </a:prstGeom>
+          <a:noFill/>
+        </p:spPr>
+        <p:txBody>
+          <a:bodyPr wrap="square" anchor="t">
+            <a:spAutoFit/>
+          </a:bodyPr>
+          <a:lstStyle/>
+          <a:p>
+            <a:pPr algn="r"/>
+            <a:r>
+              <a:rPr sz="825" b="0">
+                <a:solidFill>
+                  <a:srgbClr val="9E8E80"/>
+                </a:solidFill>
+                <a:latin typeface="Montserrat"/>
+              </a:rPr>
+              <a:t>EST. 2026 // EDITION 01</a:t>
+            </a:r>
+          </a:p>
+        </p:txBody>
+      </p:sp>
+      <p:sp>
+        <p:nvSpPr>
+          <p:cNvPr id="5" name="TextBox 4"/>
+          <p:cNvSpPr txBox="1"/>
+          <p:nvPr/>
+        </p:nvSpPr>
+        <p:spPr>
+          <a:xfrm>
+            <a:off x="619125" y="933450"/>
+            <a:ext cx="9048750" cy="904875"/>
+          </a:xfrm>
+          <a:prstGeom prst="rect">
+            <a:avLst/>
+          </a:prstGeom>
+          <a:noFill/>
+        </p:spPr>
+        <p:txBody>
+          <a:bodyPr wrap="square" anchor="t">
+            <a:spAutoFit/>
+          </a:bodyPr>
+          <a:lstStyle/>
+          <a:p>
+            <a:pPr algn="l"/>
+            <a:r>
+              <a:rPr sz="3150" b="1">
+                <a:solidFill>
+                  <a:srgbClr val="FDFBF7"/>
+                </a:solidFill>
+                <a:latin typeface="Montserrat"/>
+              </a:rPr>
+              <a:t>Artisan Coffee Masterpiece</a:t>
+            </a:r>
+          </a:p>
+        </p:txBody>
+      </p:sp>
+      <p:sp>
+        <p:nvSpPr>
+          <p:cNvPr id="6" name="TextBox 5"/>
+          <p:cNvSpPr txBox="1"/>
+          <p:nvPr/>
+        </p:nvSpPr>
+        <p:spPr>
+          <a:xfrm>
+            <a:off x="619125" y="1885950"/>
+            <a:ext cx="9048750" cy="428625"/>
+          </a:xfrm>
+          <a:prstGeom prst="rect">
+            <a:avLst/>
+          </a:prstGeom>
+          <a:noFill/>
+        </p:spPr>
+        <p:txBody>
+          <a:bodyPr wrap="square" anchor="t">
+            <a:spAutoFit/>
+          </a:bodyPr>
+          <a:lstStyle/>
+          <a:p>
+            <a:pPr algn="l"/>
+            <a:r>
+              <a:rPr sz="1200" b="0">
+                <a:solidFill>
+                  <a:srgbClr val="C8BDB0"/>
+                </a:solidFill>
+                <a:latin typeface="Montserrat"/>
+              </a:rPr>
+              <a:t>Racikan Biji Kopi Arabica Pilihan dengan Aroma Autentik &amp; Tekstur Lembut</a:t>
+            </a:r>
+          </a:p>
+        </p:txBody>
+      </p:sp>
+      <p:pic>
+        <p:nvPicPr>
+          <p:cNvPr id="7" name="Picture 6" descr="artisan_coffee.jpg"/>
+          <p:cNvPicPr>
+            <a:picLocks noChangeAspect="1"/>
+          </p:cNvPicPr>
+          <p:nvPr/>
+        </p:nvPicPr>
+        <p:blipFill>
+          <a:blip r:embed="rId2"/>
+          <a:srcRect t="18985" b="18985"/>
+          <a:stretch>
+            <a:fillRect/>
+          </a:stretch>
+        </p:blipFill>
+        <p:spPr>
+          <a:xfrm>
+            <a:off x="619125" y="2381250"/>
+            <a:ext cx="9048750" cy="4191000"/>
+          </a:xfrm>
+          <a:prstGeom prst="rect">
+            <a:avLst/>
+          </a:prstGeom>
+        </p:spPr>
+      </p:pic>
+      <p:sp>
+        <p:nvSpPr>
+          <p:cNvPr id="8" name="Rectangle 7"/>
           <p:cNvSpPr/>
           <p:nvPr/>
         </p:nvSpPr>
         <p:spPr>
           <a:xfrm>
-            <a:off x="8953500" y="11144250"/>
-            <a:ext cx="2476500" cy="2476500"/>
-          </a:xfrm>
-          <a:prstGeom prst="donut">
-            <a:avLst>
-              <a:gd name="adj" fmla="val 10000"/>
-            </a:avLst>
+            <a:off x="619125" y="2381250"/>
+            <a:ext cx="9048750" cy="4191000"/>
+          </a:xfrm>
+          <a:prstGeom prst="rect">
+            <a:avLst/>
           </a:prstGeom>
-          <a:solidFill>
-            <a:srgbClr val="E76F51"/>
-          </a:solidFill>
-          <a:ln>
-            <a:noFill/>
+          <a:noFill/>
+          <a:ln w="9525">
+            <a:solidFill>
+              <a:srgbClr val="3A2E26"/>
+            </a:solidFill>
           </a:ln>
         </p:spPr>
         <p:style>
@@ -3188,23 +3349,25 @@
       </p:sp>
       <p:sp>
         <p:nvSpPr>
-          <p:cNvPr id="4" name="4-Point Star 3"/>
+          <p:cNvPr id="9" name="Rectangle 8"/>
           <p:cNvSpPr/>
           <p:nvPr/>
         </p:nvSpPr>
         <p:spPr>
           <a:xfrm>
-            <a:off x="9239250" y="428625"/>
-            <a:ext cx="381000" cy="381000"/>
-          </a:xfrm>
-          <a:prstGeom prst="star4">
+            <a:off x="619125" y="6810375"/>
+            <a:ext cx="2914650" cy="1238250"/>
+          </a:xfrm>
+          <a:prstGeom prst="rect">
             <a:avLst/>
           </a:prstGeom>
           <a:solidFill>
-            <a:srgbClr val="F5B041"/>
+            <a:srgbClr val="241C18"/>
           </a:solidFill>
-          <a:ln>
-            <a:noFill/>
+          <a:ln w="9525">
+            <a:solidFill>
+              <a:srgbClr val="3A2E26"/>
+            </a:solidFill>
           </a:ln>
         </p:spPr>
         <p:style>
@@ -3231,20 +3394,90 @@
       </p:sp>
       <p:sp>
         <p:nvSpPr>
-          <p:cNvPr id="5" name="4-Point Star 4"/>
+          <p:cNvPr id="10" name="TextBox 9"/>
+          <p:cNvSpPr txBox="1"/>
+          <p:nvPr/>
+        </p:nvSpPr>
+        <p:spPr>
+          <a:xfrm>
+            <a:off x="771525" y="6943725"/>
+            <a:ext cx="304800" cy="266700"/>
+          </a:xfrm>
+          <a:prstGeom prst="rect">
+            <a:avLst/>
+          </a:prstGeom>
+          <a:noFill/>
+        </p:spPr>
+        <p:txBody>
+          <a:bodyPr wrap="square" anchor="t">
+            <a:spAutoFit/>
+          </a:bodyPr>
+          <a:lstStyle/>
+          <a:p>
+            <a:pPr algn="l"/>
+            <a:r>
+              <a:rPr sz="1050" b="1">
+                <a:solidFill>
+                  <a:srgbClr val="D4A373"/>
+                </a:solidFill>
+                <a:latin typeface="Montserrat"/>
+              </a:rPr>
+              <a:t>01</a:t>
+            </a:r>
+          </a:p>
+        </p:txBody>
+      </p:sp>
+      <p:sp>
+        <p:nvSpPr>
+          <p:cNvPr id="11" name="TextBox 10"/>
+          <p:cNvSpPr txBox="1"/>
+          <p:nvPr/>
+        </p:nvSpPr>
+        <p:spPr>
+          <a:xfrm>
+            <a:off x="1114425" y="6943725"/>
+            <a:ext cx="2266950" cy="266700"/>
+          </a:xfrm>
+          <a:prstGeom prst="rect">
+            <a:avLst/>
+          </a:prstGeom>
+          <a:noFill/>
+        </p:spPr>
+        <p:txBody>
+          <a:bodyPr wrap="square" anchor="t">
+            <a:spAutoFit/>
+          </a:bodyPr>
+          <a:lstStyle/>
+          <a:p>
+            <a:pPr algn="l"/>
+            <a:r>
+              <a:rPr sz="1125" b="1">
+                <a:solidFill>
+                  <a:srgbClr val="FDFBF7"/>
+                </a:solidFill>
+                <a:latin typeface="Montserrat"/>
+              </a:rPr>
+              <a:t>100% Arabica</a:t>
+            </a:r>
+          </a:p>
+        </p:txBody>
+      </p:sp>
+      <p:sp>
+        <p:nvSpPr>
+          <p:cNvPr id="12" name="Rectangle 11"/>
           <p:cNvSpPr/>
           <p:nvPr/>
         </p:nvSpPr>
         <p:spPr>
           <a:xfrm>
-            <a:off x="428625" y="6477000"/>
-            <a:ext cx="304800" cy="304800"/>
-          </a:xfrm>
-          <a:prstGeom prst="star4">
+            <a:off x="771525" y="7248525"/>
+            <a:ext cx="2609850" cy="9525"/>
+          </a:xfrm>
+          <a:prstGeom prst="rect">
             <a:avLst/>
           </a:prstGeom>
           <a:solidFill>
-            <a:srgbClr val="F5B041"/>
+            <a:srgbClr val="3A2E26"/>
           </a:solidFill>
           <a:ln>
             <a:noFill/>
@@ -3274,23 +3507,60 @@
       </p:sp>
       <p:sp>
         <p:nvSpPr>
-          <p:cNvPr id="6" name="4-Point Star 5"/>
+          <p:cNvPr id="13" name="TextBox 12"/>
+          <p:cNvSpPr txBox="1"/>
+          <p:nvPr/>
+        </p:nvSpPr>
+        <p:spPr>
+          <a:xfrm>
+            <a:off x="771525" y="7324725"/>
+            <a:ext cx="2609850" cy="619125"/>
+          </a:xfrm>
+          <a:prstGeom prst="rect">
+            <a:avLst/>
+          </a:prstGeom>
+          <a:noFill/>
+        </p:spPr>
+        <p:txBody>
+          <a:bodyPr wrap="square" anchor="t">
+            <a:spAutoFit/>
+          </a:bodyPr>
+          <a:lstStyle/>
+          <a:p>
+            <a:pPr algn="l"/>
+            <a:r>
+              <a:rPr sz="900" b="0">
+                <a:solidFill>
+                  <a:srgbClr val="C8BDB0"/>
+                </a:solidFill>
+                <a:latin typeface="Montserrat"/>
+              </a:rPr>
+              <a:t>Single Origin Aceh Gayo &amp; Toraja Kalosi terkurasi.</a:t>
+            </a:r>
+          </a:p>
+        </p:txBody>
+      </p:sp>
+      <p:sp>
+        <p:nvSpPr>
+          <p:cNvPr id="14" name="Rectangle 13"/>
           <p:cNvSpPr/>
           <p:nvPr/>
         </p:nvSpPr>
         <p:spPr>
           <a:xfrm>
-            <a:off x="9477375" y="6810375"/>
-            <a:ext cx="323850" cy="323850"/>
-          </a:xfrm>
-          <a:prstGeom prst="star4">
+            <a:off x="3686175" y="6810375"/>
+            <a:ext cx="2914650" cy="1238250"/>
+          </a:xfrm>
+          <a:prstGeom prst="rect">
             <a:avLst/>
           </a:prstGeom>
           <a:solidFill>
-            <a:srgbClr val="D4A373"/>
+            <a:srgbClr val="241C18"/>
           </a:solidFill>
-          <a:ln>
-            <a:noFill/>
+          <a:ln w="9525">
+            <a:solidFill>
+              <a:srgbClr val="3A2E26"/>
+            </a:solidFill>
           </a:ln>
         </p:spPr>
         <p:style>
@@ -3317,20 +3587,90 @@
       </p:sp>
       <p:sp>
         <p:nvSpPr>
-          <p:cNvPr id="7" name="4-Point Star 6"/>
+          <p:cNvPr id="15" name="TextBox 14"/>
+          <p:cNvSpPr txBox="1"/>
+          <p:nvPr/>
+        </p:nvSpPr>
+        <p:spPr>
+          <a:xfrm>
+            <a:off x="3838575" y="6943725"/>
+            <a:ext cx="304800" cy="266700"/>
+          </a:xfrm>
+          <a:prstGeom prst="rect">
+            <a:avLst/>
+          </a:prstGeom>
+          <a:noFill/>
+        </p:spPr>
+        <p:txBody>
+          <a:bodyPr wrap="square" anchor="t">
+            <a:spAutoFit/>
+          </a:bodyPr>
+          <a:lstStyle/>
+          <a:p>
+            <a:pPr algn="l"/>
+            <a:r>
+              <a:rPr sz="1050" b="1">
+                <a:solidFill>
+                  <a:srgbClr val="D4A373"/>
+                </a:solidFill>
+                <a:latin typeface="Montserrat"/>
+              </a:rPr>
+              <a:t>02</a:t>
+            </a:r>
+          </a:p>
+        </p:txBody>
+      </p:sp>
+      <p:sp>
+        <p:nvSpPr>
+          <p:cNvPr id="16" name="TextBox 15"/>
+          <p:cNvSpPr txBox="1"/>
+          <p:nvPr/>
+        </p:nvSpPr>
+        <p:spPr>
+          <a:xfrm>
+            <a:off x="4181475" y="6943725"/>
+            <a:ext cx="2266950" cy="266700"/>
+          </a:xfrm>
+          <a:prstGeom prst="rect">
+            <a:avLst/>
+          </a:prstGeom>
+          <a:noFill/>
+        </p:spPr>
+        <p:txBody>
+          <a:bodyPr wrap="square" anchor="t">
+            <a:spAutoFit/>
+          </a:bodyPr>
+          <a:lstStyle/>
+          <a:p>
+            <a:pPr algn="l"/>
+            <a:r>
+              <a:rPr sz="1125" b="1">
+                <a:solidFill>
+                  <a:srgbClr val="FDFBF7"/>
+                </a:solidFill>
+                <a:latin typeface="Montserrat"/>
+              </a:rPr>
+              <a:t>Fresh Roasted</a:t>
+            </a:r>
+          </a:p>
+        </p:txBody>
+      </p:sp>
+      <p:sp>
+        <p:nvSpPr>
+          <p:cNvPr id="17" name="Rectangle 16"/>
           <p:cNvSpPr/>
           <p:nvPr/>
         </p:nvSpPr>
         <p:spPr>
           <a:xfrm>
-            <a:off x="4724400" y="381000"/>
-            <a:ext cx="228600" cy="228600"/>
-          </a:xfrm>
-          <a:prstGeom prst="star4">
+            <a:off x="3838575" y="7248525"/>
+            <a:ext cx="2609850" cy="9525"/>
+          </a:xfrm>
+          <a:prstGeom prst="rect">
             <a:avLst/>
           </a:prstGeom>
           <a:solidFill>
-            <a:srgbClr val="F5B041"/>
+            <a:srgbClr val="3A2E26"/>
           </a:solidFill>
           <a:ln>
             <a:noFill/>
@@ -3360,23 +3700,60 @@
       </p:sp>
       <p:sp>
         <p:nvSpPr>
-          <p:cNvPr id="8" name="Rounded Rectangle 7"/>
+          <p:cNvPr id="18" name="TextBox 17"/>
+          <p:cNvSpPr txBox="1"/>
+          <p:nvPr/>
+        </p:nvSpPr>
+        <p:spPr>
+          <a:xfrm>
+            <a:off x="3838575" y="7324725"/>
+            <a:ext cx="2609850" cy="619125"/>
+          </a:xfrm>
+          <a:prstGeom prst="rect">
+            <a:avLst/>
+          </a:prstGeom>
+          <a:noFill/>
+        </p:spPr>
+        <p:txBody>
+          <a:bodyPr wrap="square" anchor="t">
+            <a:spAutoFit/>
+          </a:bodyPr>
+          <a:lstStyle/>
+          <a:p>
+            <a:pPr algn="l"/>
+            <a:r>
+              <a:rPr sz="900" b="0">
+                <a:solidFill>
+                  <a:srgbClr val="C8BDB0"/>
+                </a:solidFill>
+                <a:latin typeface="Montserrat"/>
+              </a:rPr>
+              <a:t>Disangrai harian berkalibrasi kurva suhu presisi.</a:t>
+            </a:r>
+          </a:p>
+        </p:txBody>
+      </p:sp>
+      <p:sp>
+        <p:nvSpPr>
+          <p:cNvPr id="19" name="Rectangle 18"/>
           <p:cNvSpPr/>
           <p:nvPr/>
         </p:nvSpPr>
         <p:spPr>
           <a:xfrm>
-            <a:off x="619125" y="476250"/>
-            <a:ext cx="3143250" cy="400050"/>
-          </a:xfrm>
-          <a:prstGeom prst="roundRect">
+            <a:off x="6753225" y="6810375"/>
+            <a:ext cx="2914650" cy="1238250"/>
+          </a:xfrm>
+          <a:prstGeom prst="rect">
             <a:avLst/>
           </a:prstGeom>
           <a:solidFill>
-            <a:srgbClr val="D4A373"/>
+            <a:srgbClr val="241C18"/>
           </a:solidFill>
-          <a:ln>
-            <a:noFill/>
+          <a:ln w="9525">
+            <a:solidFill>
+              <a:srgbClr val="3A2E26"/>
+            </a:solidFill>
           </a:ln>
         </p:spPr>
         <p:style>
@@ -3403,14 +3780,14 @@
       </p:sp>
       <p:sp>
         <p:nvSpPr>
-          <p:cNvPr id="9" name="TextBox 8"/>
+          <p:cNvPr id="20" name="TextBox 19"/>
           <p:cNvSpPr txBox="1"/>
           <p:nvPr/>
         </p:nvSpPr>
         <p:spPr>
           <a:xfrm>
-            <a:off x="619125" y="476250"/>
-            <a:ext cx="3143250" cy="400050"/>
+            <a:off x="6905625" y="6943725"/>
+            <a:ext cx="304800" cy="266700"/>
           </a:xfrm>
           <a:prstGeom prst="rect">
             <a:avLst/>
@@ -3418,34 +3795,34 @@
           <a:noFill/>
         </p:spPr>
         <p:txBody>
-          <a:bodyPr wrap="square" anchor="ctr">
+          <a:bodyPr wrap="square" anchor="t">
             <a:spAutoFit/>
           </a:bodyPr>
           <a:lstStyle/>
           <a:p>
-            <a:pPr algn="ctr"/>
-            <a:r>
-              <a:rPr sz="975" b="1">
+            <a:pPr algn="l"/>
+            <a:r>
+              <a:rPr sz="1050" b="1">
                 <a:solidFill>
-                  <a:srgbClr val="120D0A"/>
+                  <a:srgbClr val="D4A373"/>
                 </a:solidFill>
                 <a:latin typeface="Montserrat"/>
               </a:rPr>
-              <a:t>SPECIALTY ROASTERY &amp; CAFE</a:t>
-            </a:r>
-          </a:p>
-        </p:txBody>
-      </p:sp>
-      <p:sp>
-        <p:nvSpPr>
-          <p:cNvPr id="10" name="TextBox 9"/>
+              <a:t>03</a:t>
+            </a:r>
+          </a:p>
+        </p:txBody>
+      </p:sp>
+      <p:sp>
+        <p:nvSpPr>
+          <p:cNvPr id="21" name="TextBox 20"/>
           <p:cNvSpPr txBox="1"/>
           <p:nvPr/>
         </p:nvSpPr>
         <p:spPr>
           <a:xfrm>
-            <a:off x="619125" y="1000125"/>
-            <a:ext cx="9048750" cy="809625"/>
+            <a:off x="7248525" y="6943725"/>
+            <a:ext cx="2266950" cy="266700"/>
           </a:xfrm>
           <a:prstGeom prst="rect">
             <a:avLst/>
@@ -3460,68 +3837,33 @@
           <a:p>
             <a:pPr algn="l"/>
             <a:r>
-              <a:rPr sz="3000" b="1">
+              <a:rPr sz="1125" b="1">
                 <a:solidFill>
                   <a:srgbClr val="FDFBF7"/>
                 </a:solidFill>
                 <a:latin typeface="Montserrat"/>
               </a:rPr>
-              <a:t>Artisan Coffee Masterpiece</a:t>
-            </a:r>
-          </a:p>
-        </p:txBody>
-      </p:sp>
-      <p:sp>
-        <p:nvSpPr>
-          <p:cNvPr id="11" name="TextBox 10"/>
-          <p:cNvSpPr txBox="1"/>
+              <a:t>Master Barista</a:t>
+            </a:r>
+          </a:p>
+        </p:txBody>
+      </p:sp>
+      <p:sp>
+        <p:nvSpPr>
+          <p:cNvPr id="22" name="Rectangle 21"/>
+          <p:cNvSpPr/>
           <p:nvPr/>
         </p:nvSpPr>
         <p:spPr>
           <a:xfrm>
-            <a:off x="619125" y="1857375"/>
-            <a:ext cx="9048750" cy="428625"/>
+            <a:off x="6905625" y="7248525"/>
+            <a:ext cx="2609850" cy="9525"/>
           </a:xfrm>
           <a:prstGeom prst="rect">
             <a:avLst/>
           </a:prstGeom>
-          <a:noFill/>
-        </p:spPr>
-        <p:txBody>
-          <a:bodyPr wrap="square" anchor="t">
-            <a:spAutoFit/>
-          </a:bodyPr>
-          <a:lstStyle/>
-          <a:p>
-            <a:pPr algn="l"/>
-            <a:r>
-              <a:rPr sz="1275" b="0">
-                <a:solidFill>
-                  <a:srgbClr val="C8BDB0"/>
-                </a:solidFill>
-                <a:latin typeface="Montserrat"/>
-              </a:rPr>
-              <a:t>Racikan Biji Kopi Arabica Pilihan dengan Aroma Autentik &amp; Tekstur Lembut</a:t>
-            </a:r>
-          </a:p>
-        </p:txBody>
-      </p:sp>
-      <p:sp>
-        <p:nvSpPr>
-          <p:cNvPr id="12" name="Rounded Rectangle 11"/>
-          <p:cNvSpPr/>
-          <p:nvPr/>
-        </p:nvSpPr>
-        <p:spPr>
-          <a:xfrm>
-            <a:off x="561975" y="2324100"/>
-            <a:ext cx="9163050" cy="4210050"/>
-          </a:xfrm>
-          <a:prstGeom prst="roundRect">
-            <a:avLst/>
-          </a:prstGeom>
           <a:solidFill>
-            <a:srgbClr val="D4A373"/>
+            <a:srgbClr val="3A2E26"/>
           </a:solidFill>
           <a:ln>
             <a:noFill/>
@@ -3549,50 +3891,62 @@
           </a:p>
         </p:txBody>
       </p:sp>
-      <p:pic>
-        <p:nvPicPr>
-          <p:cNvPr id="13" name="Picture 12" descr="artisan_coffee.jpg"/>
-          <p:cNvPicPr>
-            <a:picLocks noChangeAspect="1"/>
-          </p:cNvPicPr>
+      <p:sp>
+        <p:nvSpPr>
+          <p:cNvPr id="23" name="TextBox 22"/>
+          <p:cNvSpPr txBox="1"/>
           <p:nvPr/>
-        </p:nvPicPr>
-        <p:blipFill>
-          <a:blip r:embed="rId2"/>
-          <a:srcRect t="19690" b="19690"/>
-          <a:stretch>
-            <a:fillRect/>
-          </a:stretch>
-        </p:blipFill>
-        <p:spPr>
-          <a:xfrm>
-            <a:off x="619125" y="2381250"/>
-            <a:ext cx="9048750" cy="4095750"/>
+        </p:nvSpPr>
+        <p:spPr>
+          <a:xfrm>
+            <a:off x="6905625" y="7324725"/>
+            <a:ext cx="2609850" cy="619125"/>
           </a:xfrm>
           <a:prstGeom prst="rect">
             <a:avLst/>
           </a:prstGeom>
-        </p:spPr>
-      </p:pic>
-      <p:sp>
-        <p:nvSpPr>
-          <p:cNvPr id="14" name="5-Point Star 13"/>
+          <a:noFill/>
+        </p:spPr>
+        <p:txBody>
+          <a:bodyPr wrap="square" anchor="t">
+            <a:spAutoFit/>
+          </a:bodyPr>
+          <a:lstStyle/>
+          <a:p>
+            <a:pPr algn="l"/>
+            <a:r>
+              <a:rPr sz="900" b="0">
+                <a:solidFill>
+                  <a:srgbClr val="C8BDB0"/>
+                </a:solidFill>
+                <a:latin typeface="Montserrat"/>
+              </a:rPr>
+              <a:t>Ekstraksi rasio ideal 1:2 bertekanan stabil 9 bar.</a:t>
+            </a:r>
+          </a:p>
+        </p:txBody>
+      </p:sp>
+      <p:sp>
+        <p:nvSpPr>
+          <p:cNvPr id="24" name="Rectangle 23"/>
           <p:cNvSpPr/>
           <p:nvPr/>
         </p:nvSpPr>
         <p:spPr>
           <a:xfrm>
-            <a:off x="8524875" y="2143125"/>
-            <a:ext cx="1333500" cy="1333500"/>
-          </a:xfrm>
-          <a:prstGeom prst="star5">
+            <a:off x="619125" y="8239125"/>
+            <a:ext cx="9048750" cy="419100"/>
+          </a:xfrm>
+          <a:prstGeom prst="rect">
             <a:avLst/>
           </a:prstGeom>
           <a:solidFill>
-            <a:srgbClr val="E76F51"/>
+            <a:srgbClr val="241C18"/>
           </a:solidFill>
-          <a:ln>
-            <a:noFill/>
+          <a:ln w="9525">
+            <a:solidFill>
+              <a:srgbClr val="3A2E26"/>
+            </a:solidFill>
           </a:ln>
         </p:spPr>
         <p:style>
@@ -3619,14 +3973,14 @@
       </p:sp>
       <p:sp>
         <p:nvSpPr>
-          <p:cNvPr id="15" name="TextBox 14"/>
+          <p:cNvPr id="25" name="TextBox 24"/>
           <p:cNvSpPr txBox="1"/>
           <p:nvPr/>
         </p:nvSpPr>
         <p:spPr>
           <a:xfrm>
-            <a:off x="8524875" y="2476500"/>
-            <a:ext cx="1333500" cy="571500"/>
+            <a:off x="619125" y="8353425"/>
+            <a:ext cx="9048750" cy="228600"/>
           </a:xfrm>
           <a:prstGeom prst="rect">
             <a:avLst/>
@@ -3634,55 +3988,45 @@
           <a:noFill/>
         </p:spPr>
         <p:txBody>
-          <a:bodyPr wrap="square" anchor="ctr">
+          <a:bodyPr wrap="square" anchor="t">
             <a:spAutoFit/>
           </a:bodyPr>
           <a:lstStyle/>
           <a:p>
             <a:pPr algn="ctr"/>
             <a:r>
-              <a:rPr sz="1350" b="1">
+              <a:rPr sz="900" b="1">
                 <a:solidFill>
-                  <a:srgbClr val="FFFFFF"/>
+                  <a:srgbClr val="D4A373"/>
                 </a:solidFill>
                 <a:latin typeface="Montserrat"/>
               </a:rPr>
-              <a:t>DISKON</a:t>
-            </a:r>
-          </a:p>
-          <a:p>
-            <a:pPr algn="ctr"/>
-            <a:r>
-              <a:rPr sz="1350" b="1">
-                <a:solidFill>
-                  <a:srgbClr val="FFFFFF"/>
-                </a:solidFill>
-                <a:latin typeface="Montserrat"/>
-              </a:rPr>
-              <a:t>25%</a:t>
-            </a:r>
-          </a:p>
-        </p:txBody>
-      </p:sp>
-      <p:sp>
-        <p:nvSpPr>
-          <p:cNvPr id="16" name="Rounded Rectangle 15"/>
+              <a:t>SKOR MUTU 94.6 SCA  ·  2.500+ ULASAN KEPUASAN PELANGGAN  ·  SERAHAN TANGAN TERTINGGI</a:t>
+            </a:r>
+          </a:p>
+        </p:txBody>
+      </p:sp>
+      <p:sp>
+        <p:nvSpPr>
+          <p:cNvPr id="26" name="Rectangle 25"/>
           <p:cNvSpPr/>
           <p:nvPr/>
         </p:nvSpPr>
         <p:spPr>
           <a:xfrm>
-            <a:off x="771525" y="6019800"/>
-            <a:ext cx="2381250" cy="342900"/>
-          </a:xfrm>
-          <a:prstGeom prst="roundRect">
+            <a:off x="619125" y="8810625"/>
+            <a:ext cx="9048750" cy="457200"/>
+          </a:xfrm>
+          <a:prstGeom prst="rect">
             <a:avLst/>
           </a:prstGeom>
           <a:solidFill>
-            <a:srgbClr val="241C18"/>
+            <a:srgbClr val="16110D"/>
           </a:solidFill>
-          <a:ln>
-            <a:noFill/>
+          <a:ln w="9525">
+            <a:solidFill>
+              <a:srgbClr val="3A2E26"/>
+            </a:solidFill>
           </a:ln>
         </p:spPr>
         <p:style>
@@ -3709,14 +4053,14 @@
       </p:sp>
       <p:sp>
         <p:nvSpPr>
-          <p:cNvPr id="17" name="TextBox 16"/>
+          <p:cNvPr id="27" name="TextBox 26"/>
           <p:cNvSpPr txBox="1"/>
           <p:nvPr/>
         </p:nvSpPr>
         <p:spPr>
           <a:xfrm>
-            <a:off x="771525" y="6019800"/>
-            <a:ext cx="2381250" cy="342900"/>
+            <a:off x="619125" y="8943975"/>
+            <a:ext cx="9048750" cy="228600"/>
           </a:xfrm>
           <a:prstGeom prst="rect">
             <a:avLst/>
@@ -3724,40 +4068,40 @@
           <a:noFill/>
         </p:spPr>
         <p:txBody>
-          <a:bodyPr wrap="square" anchor="ctr">
+          <a:bodyPr wrap="square" anchor="t">
             <a:spAutoFit/>
           </a:bodyPr>
           <a:lstStyle/>
           <a:p>
             <a:pPr algn="ctr"/>
             <a:r>
-              <a:rPr sz="975" b="1">
+              <a:rPr sz="900" b="0">
                 <a:solidFill>
-                  <a:srgbClr val="F5B041"/>
+                  <a:srgbClr val="C8BDB0"/>
                 </a:solidFill>
                 <a:latin typeface="Montserrat"/>
               </a:rPr>
-              <a:t>Fresh Brewed Everyday</a:t>
-            </a:r>
-          </a:p>
-        </p:txBody>
-      </p:sp>
-      <p:sp>
-        <p:nvSpPr>
-          <p:cNvPr id="18" name="Rounded Rectangle 17"/>
+              <a:t>JL. SENOPATI NO. 18, JAKARTA SELATAN  |  BUKA SETIAP HARI: 08.00 - 22.00 WIB</a:t>
+            </a:r>
+          </a:p>
+        </p:txBody>
+      </p:sp>
+      <p:sp>
+        <p:nvSpPr>
+          <p:cNvPr id="28" name="Rectangle 27"/>
           <p:cNvSpPr/>
           <p:nvPr/>
         </p:nvSpPr>
         <p:spPr>
           <a:xfrm>
-            <a:off x="619125" y="6715125"/>
-            <a:ext cx="2914650" cy="1285875"/>
-          </a:xfrm>
-          <a:prstGeom prst="roundRect">
+            <a:off x="619125" y="9448800"/>
+            <a:ext cx="9048750" cy="647700"/>
+          </a:xfrm>
+          <a:prstGeom prst="rect">
             <a:avLst/>
           </a:prstGeom>
           <a:solidFill>
-            <a:srgbClr val="241C18"/>
+            <a:srgbClr val="D4A373"/>
           </a:solidFill>
           <a:ln>
             <a:noFill/>
@@ -3787,57 +4131,14 @@
       </p:sp>
       <p:sp>
         <p:nvSpPr>
-          <p:cNvPr id="19" name="Hexagon 18"/>
-          <p:cNvSpPr/>
-          <p:nvPr/>
-        </p:nvSpPr>
-        <p:spPr>
-          <a:xfrm>
-            <a:off x="752475" y="6848475"/>
-            <a:ext cx="266700" cy="266700"/>
-          </a:xfrm>
-          <a:prstGeom prst="hexagon">
-            <a:avLst/>
-          </a:prstGeom>
-          <a:solidFill>
-            <a:srgbClr val="D4A373"/>
-          </a:solidFill>
-          <a:ln>
-            <a:noFill/>
-          </a:ln>
-        </p:spPr>
-        <p:style>
-          <a:lnRef idx="1">
-            <a:schemeClr val="accent1"/>
-          </a:lnRef>
-          <a:fillRef idx="3">
-            <a:schemeClr val="accent1"/>
-          </a:fillRef>
-          <a:effectRef idx="2">
-            <a:schemeClr val="accent1"/>
-          </a:effectRef>
-          <a:fontRef idx="minor">
-            <a:schemeClr val="lt1"/>
-          </a:fontRef>
-        </p:style>
-        <p:txBody>
-          <a:bodyPr rtlCol="0" anchor="ctr"/>
-          <a:lstStyle/>
-          <a:p>
-            <a:pPr algn="ctr"/>
-          </a:p>
-        </p:txBody>
-      </p:sp>
-      <p:sp>
-        <p:nvSpPr>
-          <p:cNvPr id="20" name="TextBox 19"/>
+          <p:cNvPr id="29" name="TextBox 28"/>
           <p:cNvSpPr txBox="1"/>
           <p:nvPr/>
         </p:nvSpPr>
         <p:spPr>
           <a:xfrm>
-            <a:off x="752475" y="6848475"/>
-            <a:ext cx="266700" cy="266700"/>
+            <a:off x="619125" y="9448800"/>
+            <a:ext cx="9048750" cy="647700"/>
           </a:xfrm>
           <a:prstGeom prst="rect">
             <a:avLst/>
@@ -3852,779 +4153,7 @@
           <a:p>
             <a:pPr algn="ctr"/>
             <a:r>
-              <a:rPr sz="900" b="1">
-                <a:solidFill>
-                  <a:srgbClr val="120D0A"/>
-                </a:solidFill>
-                <a:latin typeface="Montserrat"/>
-              </a:rPr>
-              <a:t>1</a:t>
-            </a:r>
-          </a:p>
-        </p:txBody>
-      </p:sp>
-      <p:sp>
-        <p:nvSpPr>
-          <p:cNvPr id="21" name="TextBox 20"/>
-          <p:cNvSpPr txBox="1"/>
-          <p:nvPr/>
-        </p:nvSpPr>
-        <p:spPr>
-          <a:xfrm>
-            <a:off x="1095375" y="6858000"/>
-            <a:ext cx="2381250" cy="247650"/>
-          </a:xfrm>
-          <a:prstGeom prst="rect">
-            <a:avLst/>
-          </a:prstGeom>
-          <a:noFill/>
-        </p:spPr>
-        <p:txBody>
-          <a:bodyPr wrap="square" anchor="t">
-            <a:spAutoFit/>
-          </a:bodyPr>
-          <a:lstStyle/>
-          <a:p>
-            <a:pPr algn="l"/>
-            <a:r>
-              <a:rPr sz="1125" b="1">
-                <a:solidFill>
-                  <a:srgbClr val="FDFBF7"/>
-                </a:solidFill>
-                <a:latin typeface="Montserrat"/>
-              </a:rPr>
-              <a:t>100% Arabica</a:t>
-            </a:r>
-          </a:p>
-        </p:txBody>
-      </p:sp>
-      <p:sp>
-        <p:nvSpPr>
-          <p:cNvPr id="22" name="TextBox 21"/>
-          <p:cNvSpPr txBox="1"/>
-          <p:nvPr/>
-        </p:nvSpPr>
-        <p:spPr>
-          <a:xfrm>
-            <a:off x="752475" y="7172325"/>
-            <a:ext cx="2647950" cy="714375"/>
-          </a:xfrm>
-          <a:prstGeom prst="rect">
-            <a:avLst/>
-          </a:prstGeom>
-          <a:noFill/>
-        </p:spPr>
-        <p:txBody>
-          <a:bodyPr wrap="square" anchor="t">
-            <a:spAutoFit/>
-          </a:bodyPr>
-          <a:lstStyle/>
-          <a:p>
-            <a:pPr algn="l"/>
-            <a:r>
-              <a:rPr sz="975" b="0">
-                <a:solidFill>
-                  <a:srgbClr val="C8BDB0"/>
-                </a:solidFill>
-                <a:latin typeface="Montserrat"/>
-              </a:rPr>
-              <a:t>Single Origin Aceh Gayo &amp; Toraja</a:t>
-            </a:r>
-          </a:p>
-        </p:txBody>
-      </p:sp>
-      <p:sp>
-        <p:nvSpPr>
-          <p:cNvPr id="23" name="Rounded Rectangle 22"/>
-          <p:cNvSpPr/>
-          <p:nvPr/>
-        </p:nvSpPr>
-        <p:spPr>
-          <a:xfrm>
-            <a:off x="3686175" y="6715125"/>
-            <a:ext cx="2914650" cy="1285875"/>
-          </a:xfrm>
-          <a:prstGeom prst="roundRect">
-            <a:avLst/>
-          </a:prstGeom>
-          <a:solidFill>
-            <a:srgbClr val="241C18"/>
-          </a:solidFill>
-          <a:ln>
-            <a:noFill/>
-          </a:ln>
-        </p:spPr>
-        <p:style>
-          <a:lnRef idx="1">
-            <a:schemeClr val="accent1"/>
-          </a:lnRef>
-          <a:fillRef idx="3">
-            <a:schemeClr val="accent1"/>
-          </a:fillRef>
-          <a:effectRef idx="2">
-            <a:schemeClr val="accent1"/>
-          </a:effectRef>
-          <a:fontRef idx="minor">
-            <a:schemeClr val="lt1"/>
-          </a:fontRef>
-        </p:style>
-        <p:txBody>
-          <a:bodyPr rtlCol="0" anchor="ctr"/>
-          <a:lstStyle/>
-          <a:p>
-            <a:pPr algn="ctr"/>
-          </a:p>
-        </p:txBody>
-      </p:sp>
-      <p:sp>
-        <p:nvSpPr>
-          <p:cNvPr id="24" name="Hexagon 23"/>
-          <p:cNvSpPr/>
-          <p:nvPr/>
-        </p:nvSpPr>
-        <p:spPr>
-          <a:xfrm>
-            <a:off x="3819525" y="6848475"/>
-            <a:ext cx="266700" cy="266700"/>
-          </a:xfrm>
-          <a:prstGeom prst="hexagon">
-            <a:avLst/>
-          </a:prstGeom>
-          <a:solidFill>
-            <a:srgbClr val="D4A373"/>
-          </a:solidFill>
-          <a:ln>
-            <a:noFill/>
-          </a:ln>
-        </p:spPr>
-        <p:style>
-          <a:lnRef idx="1">
-            <a:schemeClr val="accent1"/>
-          </a:lnRef>
-          <a:fillRef idx="3">
-            <a:schemeClr val="accent1"/>
-          </a:fillRef>
-          <a:effectRef idx="2">
-            <a:schemeClr val="accent1"/>
-          </a:effectRef>
-          <a:fontRef idx="minor">
-            <a:schemeClr val="lt1"/>
-          </a:fontRef>
-        </p:style>
-        <p:txBody>
-          <a:bodyPr rtlCol="0" anchor="ctr"/>
-          <a:lstStyle/>
-          <a:p>
-            <a:pPr algn="ctr"/>
-          </a:p>
-        </p:txBody>
-      </p:sp>
-      <p:sp>
-        <p:nvSpPr>
-          <p:cNvPr id="25" name="TextBox 24"/>
-          <p:cNvSpPr txBox="1"/>
-          <p:nvPr/>
-        </p:nvSpPr>
-        <p:spPr>
-          <a:xfrm>
-            <a:off x="3819525" y="6848475"/>
-            <a:ext cx="266700" cy="266700"/>
-          </a:xfrm>
-          <a:prstGeom prst="rect">
-            <a:avLst/>
-          </a:prstGeom>
-          <a:noFill/>
-        </p:spPr>
-        <p:txBody>
-          <a:bodyPr wrap="square" anchor="ctr">
-            <a:spAutoFit/>
-          </a:bodyPr>
-          <a:lstStyle/>
-          <a:p>
-            <a:pPr algn="ctr"/>
-            <a:r>
-              <a:rPr sz="900" b="1">
-                <a:solidFill>
-                  <a:srgbClr val="120D0A"/>
-                </a:solidFill>
-                <a:latin typeface="Montserrat"/>
-              </a:rPr>
-              <a:t>2</a:t>
-            </a:r>
-          </a:p>
-        </p:txBody>
-      </p:sp>
-      <p:sp>
-        <p:nvSpPr>
-          <p:cNvPr id="26" name="TextBox 25"/>
-          <p:cNvSpPr txBox="1"/>
-          <p:nvPr/>
-        </p:nvSpPr>
-        <p:spPr>
-          <a:xfrm>
-            <a:off x="4162425" y="6858000"/>
-            <a:ext cx="2381250" cy="247650"/>
-          </a:xfrm>
-          <a:prstGeom prst="rect">
-            <a:avLst/>
-          </a:prstGeom>
-          <a:noFill/>
-        </p:spPr>
-        <p:txBody>
-          <a:bodyPr wrap="square" anchor="t">
-            <a:spAutoFit/>
-          </a:bodyPr>
-          <a:lstStyle/>
-          <a:p>
-            <a:pPr algn="l"/>
-            <a:r>
-              <a:rPr sz="1125" b="1">
-                <a:solidFill>
-                  <a:srgbClr val="FDFBF7"/>
-                </a:solidFill>
-                <a:latin typeface="Montserrat"/>
-              </a:rPr>
-              <a:t>Fresh Roasted</a:t>
-            </a:r>
-          </a:p>
-        </p:txBody>
-      </p:sp>
-      <p:sp>
-        <p:nvSpPr>
-          <p:cNvPr id="27" name="TextBox 26"/>
-          <p:cNvSpPr txBox="1"/>
-          <p:nvPr/>
-        </p:nvSpPr>
-        <p:spPr>
-          <a:xfrm>
-            <a:off x="3819525" y="7172325"/>
-            <a:ext cx="2647950" cy="714375"/>
-          </a:xfrm>
-          <a:prstGeom prst="rect">
-            <a:avLst/>
-          </a:prstGeom>
-          <a:noFill/>
-        </p:spPr>
-        <p:txBody>
-          <a:bodyPr wrap="square" anchor="t">
-            <a:spAutoFit/>
-          </a:bodyPr>
-          <a:lstStyle/>
-          <a:p>
-            <a:pPr algn="l"/>
-            <a:r>
-              <a:rPr sz="975" b="0">
-                <a:solidFill>
-                  <a:srgbClr val="C8BDB0"/>
-                </a:solidFill>
-                <a:latin typeface="Montserrat"/>
-              </a:rPr>
-              <a:t>Disangrai harian profil rasa optimal</a:t>
-            </a:r>
-          </a:p>
-        </p:txBody>
-      </p:sp>
-      <p:sp>
-        <p:nvSpPr>
-          <p:cNvPr id="28" name="Rounded Rectangle 27"/>
-          <p:cNvSpPr/>
-          <p:nvPr/>
-        </p:nvSpPr>
-        <p:spPr>
-          <a:xfrm>
-            <a:off x="6753225" y="6715125"/>
-            <a:ext cx="2914650" cy="1285875"/>
-          </a:xfrm>
-          <a:prstGeom prst="roundRect">
-            <a:avLst/>
-          </a:prstGeom>
-          <a:solidFill>
-            <a:srgbClr val="241C18"/>
-          </a:solidFill>
-          <a:ln>
-            <a:noFill/>
-          </a:ln>
-        </p:spPr>
-        <p:style>
-          <a:lnRef idx="1">
-            <a:schemeClr val="accent1"/>
-          </a:lnRef>
-          <a:fillRef idx="3">
-            <a:schemeClr val="accent1"/>
-          </a:fillRef>
-          <a:effectRef idx="2">
-            <a:schemeClr val="accent1"/>
-          </a:effectRef>
-          <a:fontRef idx="minor">
-            <a:schemeClr val="lt1"/>
-          </a:fontRef>
-        </p:style>
-        <p:txBody>
-          <a:bodyPr rtlCol="0" anchor="ctr"/>
-          <a:lstStyle/>
-          <a:p>
-            <a:pPr algn="ctr"/>
-          </a:p>
-        </p:txBody>
-      </p:sp>
-      <p:sp>
-        <p:nvSpPr>
-          <p:cNvPr id="29" name="Hexagon 28"/>
-          <p:cNvSpPr/>
-          <p:nvPr/>
-        </p:nvSpPr>
-        <p:spPr>
-          <a:xfrm>
-            <a:off x="6886575" y="6848475"/>
-            <a:ext cx="266700" cy="266700"/>
-          </a:xfrm>
-          <a:prstGeom prst="hexagon">
-            <a:avLst/>
-          </a:prstGeom>
-          <a:solidFill>
-            <a:srgbClr val="D4A373"/>
-          </a:solidFill>
-          <a:ln>
-            <a:noFill/>
-          </a:ln>
-        </p:spPr>
-        <p:style>
-          <a:lnRef idx="1">
-            <a:schemeClr val="accent1"/>
-          </a:lnRef>
-          <a:fillRef idx="3">
-            <a:schemeClr val="accent1"/>
-          </a:fillRef>
-          <a:effectRef idx="2">
-            <a:schemeClr val="accent1"/>
-          </a:effectRef>
-          <a:fontRef idx="minor">
-            <a:schemeClr val="lt1"/>
-          </a:fontRef>
-        </p:style>
-        <p:txBody>
-          <a:bodyPr rtlCol="0" anchor="ctr"/>
-          <a:lstStyle/>
-          <a:p>
-            <a:pPr algn="ctr"/>
-          </a:p>
-        </p:txBody>
-      </p:sp>
-      <p:sp>
-        <p:nvSpPr>
-          <p:cNvPr id="30" name="TextBox 29"/>
-          <p:cNvSpPr txBox="1"/>
-          <p:nvPr/>
-        </p:nvSpPr>
-        <p:spPr>
-          <a:xfrm>
-            <a:off x="6886575" y="6848475"/>
-            <a:ext cx="266700" cy="266700"/>
-          </a:xfrm>
-          <a:prstGeom prst="rect">
-            <a:avLst/>
-          </a:prstGeom>
-          <a:noFill/>
-        </p:spPr>
-        <p:txBody>
-          <a:bodyPr wrap="square" anchor="ctr">
-            <a:spAutoFit/>
-          </a:bodyPr>
-          <a:lstStyle/>
-          <a:p>
-            <a:pPr algn="ctr"/>
-            <a:r>
-              <a:rPr sz="900" b="1">
-                <a:solidFill>
-                  <a:srgbClr val="120D0A"/>
-                </a:solidFill>
-                <a:latin typeface="Montserrat"/>
-              </a:rPr>
-              <a:t>3</a:t>
-            </a:r>
-          </a:p>
-        </p:txBody>
-      </p:sp>
-      <p:sp>
-        <p:nvSpPr>
-          <p:cNvPr id="31" name="TextBox 30"/>
-          <p:cNvSpPr txBox="1"/>
-          <p:nvPr/>
-        </p:nvSpPr>
-        <p:spPr>
-          <a:xfrm>
-            <a:off x="7229475" y="6858000"/>
-            <a:ext cx="2381250" cy="247650"/>
-          </a:xfrm>
-          <a:prstGeom prst="rect">
-            <a:avLst/>
-          </a:prstGeom>
-          <a:noFill/>
-        </p:spPr>
-        <p:txBody>
-          <a:bodyPr wrap="square" anchor="t">
-            <a:spAutoFit/>
-          </a:bodyPr>
-          <a:lstStyle/>
-          <a:p>
-            <a:pPr algn="l"/>
-            <a:r>
-              <a:rPr sz="1125" b="1">
-                <a:solidFill>
-                  <a:srgbClr val="FDFBF7"/>
-                </a:solidFill>
-                <a:latin typeface="Montserrat"/>
-              </a:rPr>
-              <a:t>Master Barista</a:t>
-            </a:r>
-          </a:p>
-        </p:txBody>
-      </p:sp>
-      <p:sp>
-        <p:nvSpPr>
-          <p:cNvPr id="32" name="TextBox 31"/>
-          <p:cNvSpPr txBox="1"/>
-          <p:nvPr/>
-        </p:nvSpPr>
-        <p:spPr>
-          <a:xfrm>
-            <a:off x="6886575" y="7172325"/>
-            <a:ext cx="2647950" cy="714375"/>
-          </a:xfrm>
-          <a:prstGeom prst="rect">
-            <a:avLst/>
-          </a:prstGeom>
-          <a:noFill/>
-        </p:spPr>
-        <p:txBody>
-          <a:bodyPr wrap="square" anchor="t">
-            <a:spAutoFit/>
-          </a:bodyPr>
-          <a:lstStyle/>
-          <a:p>
-            <a:pPr algn="l"/>
-            <a:r>
-              <a:rPr sz="975" b="0">
-                <a:solidFill>
-                  <a:srgbClr val="C8BDB0"/>
-                </a:solidFill>
-                <a:latin typeface="Montserrat"/>
-              </a:rPr>
-              <a:t>Seduhan presisi suhu &amp; rasio ideal</a:t>
-            </a:r>
-          </a:p>
-        </p:txBody>
-      </p:sp>
-      <p:sp>
-        <p:nvSpPr>
-          <p:cNvPr id="33" name="Rounded Rectangle 32"/>
-          <p:cNvSpPr/>
-          <p:nvPr/>
-        </p:nvSpPr>
-        <p:spPr>
-          <a:xfrm>
-            <a:off x="619125" y="8191500"/>
-            <a:ext cx="9048750" cy="457200"/>
-          </a:xfrm>
-          <a:prstGeom prst="roundRect">
-            <a:avLst/>
-          </a:prstGeom>
-          <a:solidFill>
-            <a:srgbClr val="241C18"/>
-          </a:solidFill>
-          <a:ln>
-            <a:noFill/>
-          </a:ln>
-        </p:spPr>
-        <p:style>
-          <a:lnRef idx="1">
-            <a:schemeClr val="accent1"/>
-          </a:lnRef>
-          <a:fillRef idx="3">
-            <a:schemeClr val="accent1"/>
-          </a:fillRef>
-          <a:effectRef idx="2">
-            <a:schemeClr val="accent1"/>
-          </a:effectRef>
-          <a:fontRef idx="minor">
-            <a:schemeClr val="lt1"/>
-          </a:fontRef>
-        </p:style>
-        <p:txBody>
-          <a:bodyPr rtlCol="0" anchor="ctr"/>
-          <a:lstStyle/>
-          <a:p>
-            <a:pPr algn="ctr"/>
-          </a:p>
-        </p:txBody>
-      </p:sp>
-      <p:sp>
-        <p:nvSpPr>
-          <p:cNvPr id="34" name="5-Point Star 33"/>
-          <p:cNvSpPr/>
-          <p:nvPr/>
-        </p:nvSpPr>
-        <p:spPr>
-          <a:xfrm>
-            <a:off x="771525" y="8305800"/>
-            <a:ext cx="228600" cy="228600"/>
-          </a:xfrm>
-          <a:prstGeom prst="star5">
-            <a:avLst/>
-          </a:prstGeom>
-          <a:solidFill>
-            <a:srgbClr val="F5B041"/>
-          </a:solidFill>
-          <a:ln>
-            <a:noFill/>
-          </a:ln>
-        </p:spPr>
-        <p:style>
-          <a:lnRef idx="1">
-            <a:schemeClr val="accent1"/>
-          </a:lnRef>
-          <a:fillRef idx="3">
-            <a:schemeClr val="accent1"/>
-          </a:fillRef>
-          <a:effectRef idx="2">
-            <a:schemeClr val="accent1"/>
-          </a:effectRef>
-          <a:fontRef idx="minor">
-            <a:schemeClr val="lt1"/>
-          </a:fontRef>
-        </p:style>
-        <p:txBody>
-          <a:bodyPr rtlCol="0" anchor="ctr"/>
-          <a:lstStyle/>
-          <a:p>
-            <a:pPr algn="ctr"/>
-          </a:p>
-        </p:txBody>
-      </p:sp>
-      <p:sp>
-        <p:nvSpPr>
-          <p:cNvPr id="35" name="TextBox 34"/>
-          <p:cNvSpPr txBox="1"/>
-          <p:nvPr/>
-        </p:nvSpPr>
-        <p:spPr>
-          <a:xfrm>
-            <a:off x="1095375" y="8191500"/>
-            <a:ext cx="8477250" cy="457200"/>
-          </a:xfrm>
-          <a:prstGeom prst="rect">
-            <a:avLst/>
-          </a:prstGeom>
-          <a:noFill/>
-        </p:spPr>
-        <p:txBody>
-          <a:bodyPr wrap="square" anchor="ctr">
-            <a:spAutoFit/>
-          </a:bodyPr>
-          <a:lstStyle/>
-          <a:p>
-            <a:pPr algn="l"/>
-            <a:r>
-              <a:rPr sz="1050" b="1">
-                <a:solidFill>
-                  <a:srgbClr val="FDFBF7"/>
-                </a:solidFill>
-                <a:latin typeface="Montserrat"/>
-              </a:rPr>
-              <a:t>Rating 4.9/5.0 dari 2.500+ Ulasan Pelanggan  ·  Pilihan Utama Pecinta Kopi</a:t>
-            </a:r>
-          </a:p>
-        </p:txBody>
-      </p:sp>
-      <p:sp>
-        <p:nvSpPr>
-          <p:cNvPr id="36" name="Rounded Rectangle 35"/>
-          <p:cNvSpPr/>
-          <p:nvPr/>
-        </p:nvSpPr>
-        <p:spPr>
-          <a:xfrm>
-            <a:off x="619125" y="8810625"/>
-            <a:ext cx="9048750" cy="495300"/>
-          </a:xfrm>
-          <a:prstGeom prst="roundRect">
-            <a:avLst/>
-          </a:prstGeom>
-          <a:solidFill>
-            <a:srgbClr val="18120F"/>
-          </a:solidFill>
-          <a:ln>
-            <a:noFill/>
-          </a:ln>
-        </p:spPr>
-        <p:style>
-          <a:lnRef idx="1">
-            <a:schemeClr val="accent1"/>
-          </a:lnRef>
-          <a:fillRef idx="3">
-            <a:schemeClr val="accent1"/>
-          </a:fillRef>
-          <a:effectRef idx="2">
-            <a:schemeClr val="accent1"/>
-          </a:effectRef>
-          <a:fontRef idx="minor">
-            <a:schemeClr val="lt1"/>
-          </a:fontRef>
-        </p:style>
-        <p:txBody>
-          <a:bodyPr rtlCol="0" anchor="ctr"/>
-          <a:lstStyle/>
-          <a:p>
-            <a:pPr algn="ctr"/>
-          </a:p>
-        </p:txBody>
-      </p:sp>
-      <p:sp>
-        <p:nvSpPr>
-          <p:cNvPr id="37" name="Chevron 36"/>
-          <p:cNvSpPr/>
-          <p:nvPr/>
-        </p:nvSpPr>
-        <p:spPr>
-          <a:xfrm>
-            <a:off x="790575" y="8972550"/>
-            <a:ext cx="171450" cy="171450"/>
-          </a:xfrm>
-          <a:prstGeom prst="chevron">
-            <a:avLst/>
-          </a:prstGeom>
-          <a:solidFill>
-            <a:srgbClr val="D4A373"/>
-          </a:solidFill>
-          <a:ln>
-            <a:noFill/>
-          </a:ln>
-        </p:spPr>
-        <p:style>
-          <a:lnRef idx="1">
-            <a:schemeClr val="accent1"/>
-          </a:lnRef>
-          <a:fillRef idx="3">
-            <a:schemeClr val="accent1"/>
-          </a:fillRef>
-          <a:effectRef idx="2">
-            <a:schemeClr val="accent1"/>
-          </a:effectRef>
-          <a:fontRef idx="minor">
-            <a:schemeClr val="lt1"/>
-          </a:fontRef>
-        </p:style>
-        <p:txBody>
-          <a:bodyPr rtlCol="0" anchor="ctr"/>
-          <a:lstStyle/>
-          <a:p>
-            <a:pPr algn="ctr"/>
-          </a:p>
-        </p:txBody>
-      </p:sp>
-      <p:sp>
-        <p:nvSpPr>
-          <p:cNvPr id="38" name="TextBox 37"/>
-          <p:cNvSpPr txBox="1"/>
-          <p:nvPr/>
-        </p:nvSpPr>
-        <p:spPr>
-          <a:xfrm>
-            <a:off x="1057275" y="8810625"/>
-            <a:ext cx="8515350" cy="495300"/>
-          </a:xfrm>
-          <a:prstGeom prst="rect">
-            <a:avLst/>
-          </a:prstGeom>
-          <a:noFill/>
-        </p:spPr>
-        <p:txBody>
-          <a:bodyPr wrap="square" anchor="ctr">
-            <a:spAutoFit/>
-          </a:bodyPr>
-          <a:lstStyle/>
-          <a:p>
-            <a:pPr algn="l"/>
-            <a:r>
-              <a:rPr sz="1050" b="0">
-                <a:solidFill>
-                  <a:srgbClr val="C8BDB0"/>
-                </a:solidFill>
-                <a:latin typeface="Montserrat"/>
-              </a:rPr>
-              <a:t>Jl. Senopati No. 18, Kebayoran Baru, Jakarta Selatan  |  Buka Setiap Hari: 08.00 - 22.00 WIB</a:t>
-            </a:r>
-          </a:p>
-        </p:txBody>
-      </p:sp>
-      <p:sp>
-        <p:nvSpPr>
-          <p:cNvPr id="39" name="Rounded Rectangle 38"/>
-          <p:cNvSpPr/>
-          <p:nvPr/>
-        </p:nvSpPr>
-        <p:spPr>
-          <a:xfrm>
-            <a:off x="619125" y="9505950"/>
-            <a:ext cx="9048750" cy="666750"/>
-          </a:xfrm>
-          <a:prstGeom prst="roundRect">
-            <a:avLst/>
-          </a:prstGeom>
-          <a:solidFill>
-            <a:srgbClr val="D4A373"/>
-          </a:solidFill>
-          <a:ln>
-            <a:noFill/>
-          </a:ln>
-        </p:spPr>
-        <p:style>
-          <a:lnRef idx="1">
-            <a:schemeClr val="accent1"/>
-          </a:lnRef>
-          <a:fillRef idx="3">
-            <a:schemeClr val="accent1"/>
-          </a:fillRef>
-          <a:effectRef idx="2">
-            <a:schemeClr val="accent1"/>
-          </a:effectRef>
-          <a:fontRef idx="minor">
-            <a:schemeClr val="lt1"/>
-          </a:fontRef>
-        </p:style>
-        <p:txBody>
-          <a:bodyPr rtlCol="0" anchor="ctr"/>
-          <a:lstStyle/>
-          <a:p>
-            <a:pPr algn="ctr"/>
-          </a:p>
-        </p:txBody>
-      </p:sp>
-      <p:sp>
-        <p:nvSpPr>
-          <p:cNvPr id="40" name="TextBox 39"/>
-          <p:cNvSpPr txBox="1"/>
-          <p:nvPr/>
-        </p:nvSpPr>
-        <p:spPr>
-          <a:xfrm>
-            <a:off x="619125" y="9505950"/>
-            <a:ext cx="9048750" cy="666750"/>
-          </a:xfrm>
-          <a:prstGeom prst="rect">
-            <a:avLst/>
-          </a:prstGeom>
-          <a:noFill/>
-        </p:spPr>
-        <p:txBody>
-          <a:bodyPr wrap="square" anchor="ctr">
-            <a:spAutoFit/>
-          </a:bodyPr>
-          <a:lstStyle/>
-          <a:p>
-            <a:pPr algn="ctr"/>
-            <a:r>
-              <a:rPr sz="1425" b="1">
+              <a:rPr sz="1275" b="1">
                 <a:solidFill>
                   <a:srgbClr val="120D0A"/>
                 </a:solidFill>
@@ -4637,14 +4166,14 @@
       </p:sp>
       <p:sp>
         <p:nvSpPr>
-          <p:cNvPr id="41" name="TextBox 40"/>
+          <p:cNvPr id="30" name="TextBox 29"/>
           <p:cNvSpPr txBox="1"/>
           <p:nvPr/>
         </p:nvSpPr>
         <p:spPr>
           <a:xfrm>
-            <a:off x="619125" y="10334625"/>
-            <a:ext cx="9048750" cy="285750"/>
+            <a:off x="619125" y="10239375"/>
+            <a:ext cx="9048750" cy="266700"/>
           </a:xfrm>
           <a:prstGeom prst="rect">
             <a:avLst/>
@@ -4659,13 +4188,13 @@
           <a:p>
             <a:pPr algn="ctr"/>
             <a:r>
-              <a:rPr sz="975" b="0">
+              <a:rPr sz="900" b="0">
                 <a:solidFill>
                   <a:srgbClr val="8D7666"/>
                 </a:solidFill>
                 <a:latin typeface="Montserrat"/>
               </a:rPr>
-              <a:t>Diseduh dengan cinta dan presisi untuk setiap cangkir berharga  ·  @artisancoffee.id</a:t>
+              <a:t>Diseduh dengan dedikasi dan presisi untuk setiap cangkir bernilai  ·  @artisancoffee.id</a:t>
             </a:r>
           </a:p>
         </p:txBody>

</xml_diff>